<commit_message>
Phase 6 iter 4: anti-pattern + Russification fixes
- Removed «75 минут» timing marker from s03 (anti-pattern fix)
- Removed LO codes from s12 + s42 visible body (LO-leak fix)
- Russified narrative anglicisms in keystone matrix labels:
  * Q1/Q2/Q3/Q4 quadrant titles
  * «essential» → «необходим», «augmentation» → «дополнение»
  * «working cases» → «рабочих кейсов», «documented failures» → «разобранных провалов»
- Updated section dividers + roadmap with RU terms (Сквозные риски)
- Charts rebuilt with proper dataset labels (no more «undefined» legend)
- Section divider Q-label sizing fixed (no overlap with subtitle)

#144
</commit_message>
<xml_diff>
--- a/library/lectures/lec-16/rendered/lec-16.pptx
+++ b/library/lectures/lec-16/rendered/lec-16.pptx
@@ -11568,7 +11568,7 @@
                 </a:solidFill>
                 <a:latin typeface="Arial"/>
               </a:rPr>
-              <a:t>LO2 — главный навык курса: уметь сказать «нет» там, где AI не нужен. 14% successful vs 86% pilot stuck — разница часто именно здесь.</a:t>
+              <a:t>Главный навык курса: уметь сказать «нет» там, где AI не нужен. 14% successful vs 86% pilot stuck — разница часто именно здесь.</a:t>
             </a:r>
           </a:p>
         </p:txBody>
@@ -12175,7 +12175,7 @@
                 </a:solidFill>
                 <a:latin typeface="Arial"/>
               </a:rPr>
-              <a:t>7. Cross-cutting</a:t>
+              <a:t>7. Сквозные</a:t>
             </a:r>
           </a:p>
         </p:txBody>
@@ -12189,7 +12189,7 @@
         <p:spPr>
           <a:xfrm>
             <a:off x="457200" y="914400"/>
-            <a:ext cx="5029200" cy="4114800"/>
+            <a:ext cx="5029200" cy="3291840"/>
           </a:xfrm>
           <a:prstGeom prst="rect">
             <a:avLst/>
@@ -12227,8 +12227,8 @@
         </p:nvSpPr>
         <p:spPr>
           <a:xfrm>
-            <a:off x="457200" y="4389120"/>
-            <a:ext cx="5029200" cy="548640"/>
+            <a:off x="457200" y="4434840"/>
+            <a:ext cx="5029200" cy="502920"/>
           </a:xfrm>
           <a:prstGeom prst="rect">
             <a:avLst/>
@@ -12247,13 +12247,13 @@
               </a:lnSpc>
             </a:pPr>
             <a:r>
-              <a:rPr sz="2400" b="1" i="0">
-                <a:solidFill>
-                  <a:srgbClr val="21295C"/>
-                </a:solidFill>
-                <a:latin typeface="Arial"/>
-              </a:rPr>
-              <a:t>Frontier exploration</a:t>
+              <a:rPr sz="2200" b="1" i="0">
+                <a:solidFill>
+                  <a:srgbClr val="21295C"/>
+                </a:solidFill>
+                <a:latin typeface="Arial"/>
+              </a:rPr>
+              <a:t>Разведка фронтиров</a:t>
             </a:r>
           </a:p>
         </p:txBody>
@@ -12292,7 +12292,7 @@
                 </a:solidFill>
                 <a:latin typeface="Arial"/>
               </a:rPr>
-              <a:t>Каждая wildcat скважина = $50–100M. Sample size 1–5 wells. ML не generalize без аналогов. Physics ground truth, AI augmentation.</a:t>
+              <a:t>Каждая wildcat-скважина = $50–100M. Размер выборки 1–5 скважин. ML не обобщается без аналогов. Physics ground truth, AI как дополнение.</a:t>
             </a:r>
           </a:p>
         </p:txBody>
@@ -12379,7 +12379,7 @@
                 </a:solidFill>
                 <a:latin typeface="Arial"/>
               </a:rPr>
-              <a:t>3 working cases · 2 провала десятилетия · HPC-гонка $100–400M на инсталляцию</a:t>
+              <a:t>3 рабочих кейса · 2 провала десятилетия · HPC-гонка $100–400M на инсталляцию</a:t>
             </a:r>
           </a:p>
         </p:txBody>
@@ -16493,7 +16493,7 @@
                 </a:solidFill>
                 <a:latin typeface="Arial"/>
               </a:rPr>
-              <a:t>7. Cross-cutting</a:t>
+              <a:t>7. Сквозные</a:t>
             </a:r>
           </a:p>
         </p:txBody>
@@ -16777,7 +16777,7 @@
                 </a:solidFill>
                 <a:latin typeface="Arial"/>
               </a:rPr>
-              <a:t>а где он либо essential, либо опасен — на материале</a:t>
+              <a:t>а где он либо необходим, либо опасен — на материале</a:t>
             </a:r>
           </a:p>
           <a:p>
@@ -16793,7 +16793,7 @@
                 </a:solidFill>
                 <a:latin typeface="Arial"/>
               </a:rPr>
-              <a:t>10 documented failures индустрии 2014–2026?</a:t>
+              <a:t>10 documented провалов индустрии 2014–2026?</a:t>
             </a:r>
           </a:p>
         </p:txBody>
@@ -19541,7 +19541,7 @@
                 </a:solidFill>
                 <a:latin typeface="Arial"/>
               </a:rPr>
-              <a:t>7. Cross-cutting</a:t>
+              <a:t>7. Сквозные</a:t>
             </a:r>
           </a:p>
         </p:txBody>
@@ -19555,7 +19555,7 @@
         <p:spPr>
           <a:xfrm>
             <a:off x="457200" y="914400"/>
-            <a:ext cx="5029200" cy="4114800"/>
+            <a:ext cx="5029200" cy="3291840"/>
           </a:xfrm>
           <a:prstGeom prst="rect">
             <a:avLst/>
@@ -19593,8 +19593,8 @@
         </p:nvSpPr>
         <p:spPr>
           <a:xfrm>
-            <a:off x="457200" y="4389120"/>
-            <a:ext cx="5029200" cy="548640"/>
+            <a:off x="457200" y="4434840"/>
+            <a:ext cx="5029200" cy="502920"/>
           </a:xfrm>
           <a:prstGeom prst="rect">
             <a:avLst/>
@@ -19613,13 +19613,13 @@
               </a:lnSpc>
             </a:pPr>
             <a:r>
-              <a:rPr sz="2400" b="1" i="0">
-                <a:solidFill>
-                  <a:srgbClr val="21295C"/>
-                </a:solidFill>
-                <a:latin typeface="Arial"/>
-              </a:rPr>
-              <a:t>Methane MRV</a:t>
+              <a:rPr sz="2200" b="1" i="0">
+                <a:solidFill>
+                  <a:srgbClr val="21295C"/>
+                </a:solidFill>
+                <a:latin typeface="Arial"/>
+              </a:rPr>
+              <a:t>Метановая MRV</a:t>
             </a:r>
           </a:p>
         </p:txBody>
@@ -19658,7 +19658,7 @@
                 </a:solidFill>
                 <a:latin typeface="Arial"/>
               </a:rPr>
-              <a:t>Данные — петабайты в день. Физика — разорвана. Слияние 4 сенсоров + атрибуция малой утечки — открытая ML-задача. AI essential. Но один спутник = catastrophic SPOF.</a:t>
+              <a:t>Данные — петабайты в день. Физика — разорвана. Слияние 4 сенсоров + атрибуция малой утечки — открытая ML-задача. AI необходим. Но один спутник = катастрофическая единичная уязвимость.</a:t>
             </a:r>
           </a:p>
         </p:txBody>
@@ -19745,7 +19745,7 @@
                 </a:solidFill>
                 <a:latin typeface="Arial"/>
               </a:rPr>
-              <a:t>4 working systems · 2 провала · regulatory pressure из EU 2024/1787</a:t>
+              <a:t>4 рабочих системы · 2 провала · регуляторное давление из EU 2024/1787</a:t>
             </a:r>
           </a:p>
         </p:txBody>
@@ -24961,7 +24961,7 @@
                 </a:solidFill>
                 <a:latin typeface="Arial"/>
               </a:rPr>
-              <a:t>7. Cross-cutting</a:t>
+              <a:t>7. Сквозные</a:t>
             </a:r>
           </a:p>
         </p:txBody>
@@ -24975,7 +24975,7 @@
         <p:spPr>
           <a:xfrm>
             <a:off x="457200" y="914400"/>
-            <a:ext cx="5029200" cy="4114800"/>
+            <a:ext cx="5029200" cy="3291840"/>
           </a:xfrm>
           <a:prstGeom prst="rect">
             <a:avLst/>
@@ -25013,8 +25013,8 @@
         </p:nvSpPr>
         <p:spPr>
           <a:xfrm>
-            <a:off x="457200" y="4389120"/>
-            <a:ext cx="5029200" cy="548640"/>
+            <a:off x="457200" y="4434840"/>
+            <a:ext cx="5029200" cy="502920"/>
           </a:xfrm>
           <a:prstGeom prst="rect">
             <a:avLst/>
@@ -25033,13 +25033,13 @@
               </a:lnSpc>
             </a:pPr>
             <a:r>
-              <a:rPr sz="2400" b="1" i="0">
-                <a:solidFill>
-                  <a:srgbClr val="21295C"/>
-                </a:solidFill>
-                <a:latin typeface="Arial"/>
-              </a:rPr>
-              <a:t>Energy transition: CCS + EGS</a:t>
+              <a:rPr sz="2200" b="1" i="0">
+                <a:solidFill>
+                  <a:srgbClr val="21295C"/>
+                </a:solidFill>
+                <a:latin typeface="Arial"/>
+              </a:rPr>
+              <a:t>Энергопереход: CCS + EGS</a:t>
             </a:r>
           </a:p>
         </p:txBody>
@@ -25078,7 +25078,7 @@
                 </a:solidFill>
                 <a:latin typeface="Arial"/>
               </a:rPr>
-              <a:t>Здесь AI и физика struggle вместе. Long-horizon, low-data, low-physics-certainty. Самый честный квадрант.</a:t>
+              <a:t>Здесь AI и физика буксуют вместе. Long-horizon, low-data, low-physics-certainty. Самый честный квадрант.</a:t>
             </a:r>
           </a:p>
         </p:txBody>
@@ -25165,7 +25165,7 @@
                 </a:solidFill>
                 <a:latin typeface="Arial"/>
               </a:rPr>
-              <a:t>2 working pilots · 2 структурных провала · 190× scale-up gap</a:t>
+              <a:t>2 рабочих пилота · 2 структурных провала · 190× разрыв масштабирования</a:t>
             </a:r>
           </a:p>
         </p:txBody>
@@ -25613,10 +25613,11 @@
                 </a:solidFill>
                 <a:latin typeface="Arial"/>
               </a:rPr>
-              <a:t>75 минут
-· 42 слайда
-· 10 documented
+              <a:t>42 слайда
+· 10 разобранных
 провалов
+· 12+ рабочих
+кейсов
 · 7 разделов</a:t>
             </a:r>
           </a:p>
@@ -25794,7 +25795,7 @@
 · Применять критерии
 «AI не нужен»
 · Альтернативы
-не-AI</a:t>
+без AI</a:t>
             </a:r>
           </a:p>
         </p:txBody>
@@ -25881,7 +25882,7 @@
                 </a:solidFill>
                 <a:latin typeface="Arial"/>
               </a:rPr>
-              <a:t>10 documented failures + 12+ working cases = инженерный фильтр, не каталог инноваций.</a:t>
+              <a:t>10 разобранных провалов + 12+ рабочих кейсов = инженерный фильтр, не каталог инноваций.</a:t>
             </a:r>
           </a:p>
         </p:txBody>
@@ -29489,7 +29490,7 @@
                 </a:solidFill>
                 <a:latin typeface="Arial"/>
               </a:rPr>
-              <a:t>7. Cross-cutting</a:t>
+              <a:t>7. Сквозные</a:t>
             </a:r>
           </a:p>
         </p:txBody>
@@ -33752,7 +33753,7 @@
                 </a:solidFill>
                 <a:latin typeface="Arial"/>
               </a:rPr>
-              <a:t>3 cases · 2 провала</a:t>
+              <a:t>3 кейса · 2 провала</a:t>
             </a:r>
           </a:p>
         </p:txBody>
@@ -34000,7 +34001,7 @@
                 </a:solidFill>
                 <a:latin typeface="Arial"/>
               </a:rPr>
-              <a:t>3 cases · 2 провала</a:t>
+              <a:t>3 кейса · 2 провала</a:t>
             </a:r>
           </a:p>
         </p:txBody>
@@ -34248,7 +34249,7 @@
                 </a:solidFill>
                 <a:latin typeface="Arial"/>
               </a:rPr>
-              <a:t>4 systems · 2 провала</a:t>
+              <a:t>4 системы · 2 провала</a:t>
             </a:r>
           </a:p>
         </p:txBody>
@@ -34496,7 +34497,7 @@
                 </a:solidFill>
                 <a:latin typeface="Arial"/>
               </a:rPr>
-              <a:t>2 pilots · 2 провала</a:t>
+              <a:t>2 пилота · 2 провала</a:t>
             </a:r>
           </a:p>
         </p:txBody>
@@ -34744,7 +34745,7 @@
                 </a:solidFill>
                 <a:latin typeface="Arial"/>
               </a:rPr>
-              <a:t>3 programs</a:t>
+              <a:t>3 программы</a:t>
             </a:r>
           </a:p>
         </p:txBody>
@@ -34783,7 +34784,7 @@
                 </a:solidFill>
                 <a:latin typeface="Arial"/>
               </a:rPr>
-              <a:t>Sanctions, insourcing</a:t>
+              <a:t>Санкции, инсорсинг</a:t>
             </a:r>
           </a:p>
         </p:txBody>
@@ -34953,7 +34954,7 @@
                 </a:solidFill>
                 <a:latin typeface="Arial"/>
               </a:rPr>
-              <a:t>Cross-cutting</a:t>
+              <a:t>Сквозные риски</a:t>
             </a:r>
           </a:p>
         </p:txBody>
@@ -34992,7 +34993,7 @@
                 </a:solidFill>
                 <a:latin typeface="Arial"/>
               </a:rPr>
-              <a:t>2 failures</a:t>
+              <a:t>2 провала</a:t>
             </a:r>
           </a:p>
         </p:txBody>
@@ -37040,86 +37041,8 @@
         </p:nvSpPr>
         <p:spPr>
           <a:xfrm>
-            <a:off x="457200" y="1965960"/>
-            <a:ext cx="1188720" cy="457200"/>
-          </a:xfrm>
-          <a:prstGeom prst="rect">
-            <a:avLst/>
-          </a:prstGeom>
-          <a:noFill/>
-        </p:spPr>
-        <p:txBody>
-          <a:bodyPr wrap="square" lIns="0" rIns="0" tIns="0" bIns="0" anchor="t">
-            <a:spAutoFit/>
-          </a:bodyPr>
-          <a:lstStyle/>
-          <a:p>
-            <a:pPr algn="ctr">
-              <a:lnSpc>
-                <a:spcPct val="115000"/>
-              </a:lnSpc>
-            </a:pPr>
-            <a:r>
-              <a:rPr sz="2200" b="1" i="0">
-                <a:solidFill>
-                  <a:srgbClr val="FFFFFF"/>
-                </a:solidFill>
-                <a:latin typeface="Arial"/>
-              </a:rPr>
-              <a:t>Q1</a:t>
-            </a:r>
-          </a:p>
-        </p:txBody>
-      </p:sp>
-      <p:sp>
-        <p:nvSpPr>
-          <p:cNvPr id="7" name="TextBox 6"/>
-          <p:cNvSpPr txBox="1"/>
-          <p:nvPr/>
-        </p:nvSpPr>
-        <p:spPr>
-          <a:xfrm>
-            <a:off x="457200" y="2514600"/>
-            <a:ext cx="1188720" cy="365760"/>
-          </a:xfrm>
-          <a:prstGeom prst="rect">
-            <a:avLst/>
-          </a:prstGeom>
-          <a:noFill/>
-        </p:spPr>
-        <p:txBody>
-          <a:bodyPr wrap="square" lIns="0" rIns="0" tIns="0" bIns="0" anchor="t">
-            <a:spAutoFit/>
-          </a:bodyPr>
-          <a:lstStyle/>
-          <a:p>
-            <a:pPr algn="ctr">
-              <a:lnSpc>
-                <a:spcPct val="115000"/>
-              </a:lnSpc>
-            </a:pPr>
-            <a:r>
-              <a:rPr sz="1000" b="0" i="1">
-                <a:solidFill>
-                  <a:srgbClr val="FFFFFF"/>
-                </a:solidFill>
-                <a:latin typeface="Arial"/>
-              </a:rPr>
-              <a:t>LO1</a:t>
-            </a:r>
-          </a:p>
-        </p:txBody>
-      </p:sp>
-      <p:sp>
-        <p:nvSpPr>
-          <p:cNvPr id="8" name="TextBox 7"/>
-          <p:cNvSpPr txBox="1"/>
-          <p:nvPr/>
-        </p:nvSpPr>
-        <p:spPr>
-          <a:xfrm>
-            <a:off x="1828800" y="1965960"/>
-            <a:ext cx="9720072" cy="1005839"/>
+            <a:off x="457200" y="2194560"/>
+            <a:ext cx="1188720" cy="548640"/>
           </a:xfrm>
           <a:prstGeom prst="rect">
             <a:avLst/>
@@ -37132,6 +37055,45 @@
           </a:bodyPr>
           <a:lstStyle/>
           <a:p>
+            <a:pPr algn="ctr">
+              <a:lnSpc>
+                <a:spcPct val="115000"/>
+              </a:lnSpc>
+            </a:pPr>
+            <a:r>
+              <a:rPr sz="2800" b="1" i="0">
+                <a:solidFill>
+                  <a:srgbClr val="FFFFFF"/>
+                </a:solidFill>
+                <a:latin typeface="Arial"/>
+              </a:rPr>
+              <a:t>Q1</a:t>
+            </a:r>
+          </a:p>
+        </p:txBody>
+      </p:sp>
+      <p:sp>
+        <p:nvSpPr>
+          <p:cNvPr id="7" name="TextBox 6"/>
+          <p:cNvSpPr txBox="1"/>
+          <p:nvPr/>
+        </p:nvSpPr>
+        <p:spPr>
+          <a:xfrm>
+            <a:off x="1828800" y="1965960"/>
+            <a:ext cx="9720072" cy="1005839"/>
+          </a:xfrm>
+          <a:prstGeom prst="rect">
+            <a:avLst/>
+          </a:prstGeom>
+          <a:noFill/>
+        </p:spPr>
+        <p:txBody>
+          <a:bodyPr wrap="square" lIns="0" rIns="0" tIns="0" bIns="0" anchor="ctr">
+            <a:spAutoFit/>
+          </a:bodyPr>
+          <a:lstStyle/>
+          <a:p>
             <a:pPr algn="l">
               <a:lnSpc>
                 <a:spcPct val="135000"/>
@@ -37151,7 +37113,7 @@
       </p:sp>
       <p:sp>
         <p:nvSpPr>
-          <p:cNvPr id="9" name="Rounded Rectangle 8"/>
+          <p:cNvPr id="8" name="Rounded Rectangle 7"/>
           <p:cNvSpPr/>
           <p:nvPr/>
         </p:nvSpPr>
@@ -37199,7 +37161,7 @@
       </p:sp>
       <p:sp>
         <p:nvSpPr>
-          <p:cNvPr id="10" name="Rectangle 9"/>
+          <p:cNvPr id="9" name="Rectangle 8"/>
           <p:cNvSpPr/>
           <p:nvPr/>
         </p:nvSpPr>
@@ -37243,92 +37205,14 @@
       </p:sp>
       <p:sp>
         <p:nvSpPr>
-          <p:cNvPr id="11" name="TextBox 10"/>
+          <p:cNvPr id="10" name="TextBox 9"/>
           <p:cNvSpPr txBox="1"/>
           <p:nvPr/>
         </p:nvSpPr>
         <p:spPr>
           <a:xfrm>
-            <a:off x="457200" y="3383279"/>
-            <a:ext cx="1188720" cy="457200"/>
-          </a:xfrm>
-          <a:prstGeom prst="rect">
-            <a:avLst/>
-          </a:prstGeom>
-          <a:noFill/>
-        </p:spPr>
-        <p:txBody>
-          <a:bodyPr wrap="square" lIns="0" rIns="0" tIns="0" bIns="0" anchor="t">
-            <a:spAutoFit/>
-          </a:bodyPr>
-          <a:lstStyle/>
-          <a:p>
-            <a:pPr algn="ctr">
-              <a:lnSpc>
-                <a:spcPct val="115000"/>
-              </a:lnSpc>
-            </a:pPr>
-            <a:r>
-              <a:rPr sz="2200" b="1" i="0">
-                <a:solidFill>
-                  <a:srgbClr val="FFFFFF"/>
-                </a:solidFill>
-                <a:latin typeface="Arial"/>
-              </a:rPr>
-              <a:t>Q2</a:t>
-            </a:r>
-          </a:p>
-        </p:txBody>
-      </p:sp>
-      <p:sp>
-        <p:nvSpPr>
-          <p:cNvPr id="12" name="TextBox 11"/>
-          <p:cNvSpPr txBox="1"/>
-          <p:nvPr/>
-        </p:nvSpPr>
-        <p:spPr>
-          <a:xfrm>
-            <a:off x="457200" y="3931920"/>
-            <a:ext cx="1188720" cy="365760"/>
-          </a:xfrm>
-          <a:prstGeom prst="rect">
-            <a:avLst/>
-          </a:prstGeom>
-          <a:noFill/>
-        </p:spPr>
-        <p:txBody>
-          <a:bodyPr wrap="square" lIns="0" rIns="0" tIns="0" bIns="0" anchor="t">
-            <a:spAutoFit/>
-          </a:bodyPr>
-          <a:lstStyle/>
-          <a:p>
-            <a:pPr algn="ctr">
-              <a:lnSpc>
-                <a:spcPct val="115000"/>
-              </a:lnSpc>
-            </a:pPr>
-            <a:r>
-              <a:rPr sz="1000" b="0" i="1">
-                <a:solidFill>
-                  <a:srgbClr val="FFFFFF"/>
-                </a:solidFill>
-                <a:latin typeface="Arial"/>
-              </a:rPr>
-              <a:t>LO2 + cross</a:t>
-            </a:r>
-          </a:p>
-        </p:txBody>
-      </p:sp>
-      <p:sp>
-        <p:nvSpPr>
-          <p:cNvPr id="13" name="TextBox 12"/>
-          <p:cNvSpPr txBox="1"/>
-          <p:nvPr/>
-        </p:nvSpPr>
-        <p:spPr>
-          <a:xfrm>
-            <a:off x="1828800" y="3383279"/>
-            <a:ext cx="9720072" cy="1005839"/>
+            <a:off x="457200" y="3611879"/>
+            <a:ext cx="1188720" cy="548640"/>
           </a:xfrm>
           <a:prstGeom prst="rect">
             <a:avLst/>
@@ -37341,6 +37225,45 @@
           </a:bodyPr>
           <a:lstStyle/>
           <a:p>
+            <a:pPr algn="ctr">
+              <a:lnSpc>
+                <a:spcPct val="115000"/>
+              </a:lnSpc>
+            </a:pPr>
+            <a:r>
+              <a:rPr sz="2800" b="1" i="0">
+                <a:solidFill>
+                  <a:srgbClr val="FFFFFF"/>
+                </a:solidFill>
+                <a:latin typeface="Arial"/>
+              </a:rPr>
+              <a:t>Q2</a:t>
+            </a:r>
+          </a:p>
+        </p:txBody>
+      </p:sp>
+      <p:sp>
+        <p:nvSpPr>
+          <p:cNvPr id="11" name="TextBox 10"/>
+          <p:cNvSpPr txBox="1"/>
+          <p:nvPr/>
+        </p:nvSpPr>
+        <p:spPr>
+          <a:xfrm>
+            <a:off x="1828800" y="3383279"/>
+            <a:ext cx="9720072" cy="1005839"/>
+          </a:xfrm>
+          <a:prstGeom prst="rect">
+            <a:avLst/>
+          </a:prstGeom>
+          <a:noFill/>
+        </p:spPr>
+        <p:txBody>
+          <a:bodyPr wrap="square" lIns="0" rIns="0" tIns="0" bIns="0" anchor="ctr">
+            <a:spAutoFit/>
+          </a:bodyPr>
+          <a:lstStyle/>
+          <a:p>
             <a:pPr algn="l">
               <a:lnSpc>
                 <a:spcPct val="135000"/>
@@ -37360,7 +37283,7 @@
       </p:sp>
       <p:sp>
         <p:nvSpPr>
-          <p:cNvPr id="14" name="Rounded Rectangle 13"/>
+          <p:cNvPr id="12" name="Rounded Rectangle 11"/>
           <p:cNvSpPr/>
           <p:nvPr/>
         </p:nvSpPr>
@@ -37408,7 +37331,7 @@
       </p:sp>
       <p:sp>
         <p:nvSpPr>
-          <p:cNvPr id="15" name="Rectangle 14"/>
+          <p:cNvPr id="13" name="Rectangle 12"/>
           <p:cNvSpPr/>
           <p:nvPr/>
         </p:nvSpPr>
@@ -37452,92 +37375,14 @@
       </p:sp>
       <p:sp>
         <p:nvSpPr>
-          <p:cNvPr id="16" name="TextBox 15"/>
+          <p:cNvPr id="14" name="TextBox 13"/>
           <p:cNvSpPr txBox="1"/>
           <p:nvPr/>
         </p:nvSpPr>
         <p:spPr>
           <a:xfrm>
-            <a:off x="457200" y="4800600"/>
-            <a:ext cx="1188720" cy="457200"/>
-          </a:xfrm>
-          <a:prstGeom prst="rect">
-            <a:avLst/>
-          </a:prstGeom>
-          <a:noFill/>
-        </p:spPr>
-        <p:txBody>
-          <a:bodyPr wrap="square" lIns="0" rIns="0" tIns="0" bIns="0" anchor="t">
-            <a:spAutoFit/>
-          </a:bodyPr>
-          <a:lstStyle/>
-          <a:p>
-            <a:pPr algn="ctr">
-              <a:lnSpc>
-                <a:spcPct val="115000"/>
-              </a:lnSpc>
-            </a:pPr>
-            <a:r>
-              <a:rPr sz="2200" b="1" i="0">
-                <a:solidFill>
-                  <a:srgbClr val="FFFFFF"/>
-                </a:solidFill>
-                <a:latin typeface="Arial"/>
-              </a:rPr>
-              <a:t>Q3</a:t>
-            </a:r>
-          </a:p>
-        </p:txBody>
-      </p:sp>
-      <p:sp>
-        <p:nvSpPr>
-          <p:cNvPr id="17" name="TextBox 16"/>
-          <p:cNvSpPr txBox="1"/>
-          <p:nvPr/>
-        </p:nvSpPr>
-        <p:spPr>
-          <a:xfrm>
-            <a:off x="457200" y="5349240"/>
-            <a:ext cx="1188720" cy="365760"/>
-          </a:xfrm>
-          <a:prstGeom prst="rect">
-            <a:avLst/>
-          </a:prstGeom>
-          <a:noFill/>
-        </p:spPr>
-        <p:txBody>
-          <a:bodyPr wrap="square" lIns="0" rIns="0" tIns="0" bIns="0" anchor="t">
-            <a:spAutoFit/>
-          </a:bodyPr>
-          <a:lstStyle/>
-          <a:p>
-            <a:pPr algn="ctr">
-              <a:lnSpc>
-                <a:spcPct val="115000"/>
-              </a:lnSpc>
-            </a:pPr>
-            <a:r>
-              <a:rPr sz="1000" b="0" i="1">
-                <a:solidFill>
-                  <a:srgbClr val="FFFFFF"/>
-                </a:solidFill>
-                <a:latin typeface="Arial"/>
-              </a:rPr>
-              <a:t>LO2 + LO3</a:t>
-            </a:r>
-          </a:p>
-        </p:txBody>
-      </p:sp>
-      <p:sp>
-        <p:nvSpPr>
-          <p:cNvPr id="18" name="TextBox 17"/>
-          <p:cNvSpPr txBox="1"/>
-          <p:nvPr/>
-        </p:nvSpPr>
-        <p:spPr>
-          <a:xfrm>
-            <a:off x="1828800" y="4800600"/>
-            <a:ext cx="9720072" cy="1005839"/>
+            <a:off x="457200" y="5029200"/>
+            <a:ext cx="1188720" cy="548640"/>
           </a:xfrm>
           <a:prstGeom prst="rect">
             <a:avLst/>
@@ -37550,6 +37395,45 @@
           </a:bodyPr>
           <a:lstStyle/>
           <a:p>
+            <a:pPr algn="ctr">
+              <a:lnSpc>
+                <a:spcPct val="115000"/>
+              </a:lnSpc>
+            </a:pPr>
+            <a:r>
+              <a:rPr sz="2800" b="1" i="0">
+                <a:solidFill>
+                  <a:srgbClr val="FFFFFF"/>
+                </a:solidFill>
+                <a:latin typeface="Arial"/>
+              </a:rPr>
+              <a:t>Q3</a:t>
+            </a:r>
+          </a:p>
+        </p:txBody>
+      </p:sp>
+      <p:sp>
+        <p:nvSpPr>
+          <p:cNvPr id="15" name="TextBox 14"/>
+          <p:cNvSpPr txBox="1"/>
+          <p:nvPr/>
+        </p:nvSpPr>
+        <p:spPr>
+          <a:xfrm>
+            <a:off x="1828800" y="4800600"/>
+            <a:ext cx="9720072" cy="1005839"/>
+          </a:xfrm>
+          <a:prstGeom prst="rect">
+            <a:avLst/>
+          </a:prstGeom>
+          <a:noFill/>
+        </p:spPr>
+        <p:txBody>
+          <a:bodyPr wrap="square" lIns="0" rIns="0" tIns="0" bIns="0" anchor="ctr">
+            <a:spAutoFit/>
+          </a:bodyPr>
+          <a:lstStyle/>
+          <a:p>
             <a:pPr algn="l">
               <a:lnSpc>
                 <a:spcPct val="135000"/>
@@ -37569,7 +37453,7 @@
       </p:sp>
       <p:sp>
         <p:nvSpPr>
-          <p:cNvPr id="19" name="Rounded Rectangle 18"/>
+          <p:cNvPr id="16" name="Rounded Rectangle 15"/>
           <p:cNvSpPr/>
           <p:nvPr/>
         </p:nvSpPr>
@@ -37617,7 +37501,7 @@
       </p:sp>
       <p:sp>
         <p:nvSpPr>
-          <p:cNvPr id="20" name="TextBox 19"/>
+          <p:cNvPr id="17" name="TextBox 16"/>
           <p:cNvSpPr txBox="1"/>
           <p:nvPr/>
         </p:nvSpPr>
@@ -37696,8 +37580,8 @@
         </p:blipFill>
         <p:spPr>
           <a:xfrm>
-            <a:off x="457200" y="801876"/>
-            <a:ext cx="7315200" cy="4339846"/>
+            <a:off x="457200" y="718964"/>
+            <a:ext cx="7132320" cy="4231350"/>
           </a:xfrm>
           <a:prstGeom prst="rect">
             <a:avLst/>
@@ -37712,8 +37596,8 @@
         </p:nvSpPr>
         <p:spPr>
           <a:xfrm>
-            <a:off x="457200" y="5623560"/>
-            <a:ext cx="7315200" cy="274320"/>
+            <a:off x="457200" y="5349240"/>
+            <a:ext cx="7132320" cy="274320"/>
           </a:xfrm>
           <a:prstGeom prst="rect">
             <a:avLst/>
@@ -37751,8 +37635,8 @@
         </p:nvSpPr>
         <p:spPr>
           <a:xfrm>
-            <a:off x="8046720" y="548640"/>
-            <a:ext cx="3749039" cy="5029200"/>
+            <a:off x="7680960" y="457200"/>
+            <a:ext cx="4206240" cy="5029200"/>
           </a:xfrm>
           <a:prstGeom prst="rect">
             <a:avLst/>
@@ -37767,11 +37651,59 @@
           <a:p>
             <a:pPr algn="l">
               <a:lnSpc>
-                <a:spcPct val="125000"/>
-              </a:lnSpc>
-            </a:pPr>
-            <a:r>
-              <a:rPr sz="1400" b="1" i="0">
+                <a:spcPct val="120000"/>
+              </a:lnSpc>
+            </a:pPr>
+            <a:r>
+              <a:rPr sz="2200" b="1" i="0">
+                <a:solidFill>
+                  <a:srgbClr val="21295C"/>
+                </a:solidFill>
+                <a:latin typeface="Arial"/>
+              </a:rPr>
+              <a:t>Спутник потерян —</a:t>
+            </a:r>
+          </a:p>
+          <a:p>
+            <a:pPr algn="l">
+              <a:lnSpc>
+                <a:spcPct val="120000"/>
+              </a:lnSpc>
+            </a:pPr>
+            <a:r>
+              <a:rPr sz="2600" b="1" i="0">
+                <a:solidFill>
+                  <a:srgbClr val="F0AB00"/>
+                </a:solidFill>
+                <a:latin typeface="Arial"/>
+              </a:rPr>
+              <a:t>карта осталась.</a:t>
+            </a:r>
+          </a:p>
+          <a:p>
+            <a:pPr algn="l">
+              <a:lnSpc>
+                <a:spcPct val="120000"/>
+              </a:lnSpc>
+            </a:pPr>
+            <a:r>
+              <a:rPr sz="1200" b="0" i="0">
+                <a:solidFill>
+                  <a:srgbClr val="21295C"/>
+                </a:solidFill>
+                <a:latin typeface="Arial"/>
+              </a:rPr>
+              <a:t/>
+            </a:r>
+          </a:p>
+          <a:p>
+            <a:pPr algn="l">
+              <a:lnSpc>
+                <a:spcPct val="120000"/>
+              </a:lnSpc>
+            </a:pPr>
+            <a:r>
+              <a:rPr sz="1300" b="1" i="0">
                 <a:solidFill>
                   <a:srgbClr val="065A82"/>
                 </a:solidFill>
@@ -37783,11 +37715,43 @@
           <a:p>
             <a:pPr algn="l">
               <a:lnSpc>
-                <a:spcPct val="125000"/>
-              </a:lnSpc>
-            </a:pPr>
-            <a:r>
-              <a:rPr sz="400" b="0" i="0">
+                <a:spcPct val="120000"/>
+              </a:lnSpc>
+            </a:pPr>
+            <a:r>
+              <a:rPr sz="1100" b="0" i="0">
+                <a:solidFill>
+                  <a:srgbClr val="21295C"/>
+                </a:solidFill>
+                <a:latin typeface="Arial"/>
+              </a:rPr>
+              <a:t>· 20 июня 2025 — потеря MethaneSAT</a:t>
+            </a:r>
+          </a:p>
+          <a:p>
+            <a:pPr algn="l">
+              <a:lnSpc>
+                <a:spcPct val="120000"/>
+              </a:lnSpc>
+            </a:pPr>
+            <a:r>
+              <a:rPr sz="1100" b="0" i="1">
+                <a:solidFill>
+                  <a:srgbClr val="21295C"/>
+                </a:solidFill>
+                <a:latin typeface="Arial"/>
+              </a:rPr>
+              <a:t>· ~2 000 data files за 15,5 мес → retrospective inventory</a:t>
+            </a:r>
+          </a:p>
+          <a:p>
+            <a:pPr algn="l">
+              <a:lnSpc>
+                <a:spcPct val="120000"/>
+              </a:lnSpc>
+            </a:pPr>
+            <a:r>
+              <a:rPr sz="800" b="0" i="0">
                 <a:solidFill>
                   <a:srgbClr val="21295C"/>
                 </a:solidFill>
@@ -37799,7 +37763,23 @@
           <a:p>
             <a:pPr algn="l">
               <a:lnSpc>
-                <a:spcPct val="125000"/>
+                <a:spcPct val="120000"/>
+              </a:lnSpc>
+            </a:pPr>
+            <a:r>
+              <a:rPr sz="1300" b="1" i="0">
+                <a:solidFill>
+                  <a:srgbClr val="065A82"/>
+                </a:solidFill>
+                <a:latin typeface="Arial"/>
+              </a:rPr>
+              <a:t>Final framing:</a:t>
+            </a:r>
+          </a:p>
+          <a:p>
+            <a:pPr algn="l">
+              <a:lnSpc>
+                <a:spcPct val="120000"/>
               </a:lnSpc>
             </a:pPr>
             <a:r>
@@ -37809,49 +37789,65 @@
                 </a:solidFill>
                 <a:latin typeface="Arial"/>
               </a:rPr>
-              <a:t>· Спутник потерян 20 июня 2025</a:t>
-            </a:r>
-          </a:p>
-          <a:p>
-            <a:pPr algn="l">
-              <a:lnSpc>
-                <a:spcPct val="125000"/>
-              </a:lnSpc>
-            </a:pPr>
-            <a:r>
-              <a:rPr sz="1400" b="1" i="0">
+              <a:t>AI в нефтегазе — это</a:t>
+            </a:r>
+          </a:p>
+          <a:p>
+            <a:pPr algn="l">
+              <a:lnSpc>
+                <a:spcPct val="120000"/>
+              </a:lnSpc>
+            </a:pPr>
+            <a:r>
+              <a:rPr sz="1300" b="1" i="0">
+                <a:solidFill>
+                  <a:srgbClr val="21295C"/>
+                </a:solidFill>
+                <a:latin typeface="Arial"/>
+              </a:rPr>
+              <a:t>измеримый успех</a:t>
+            </a:r>
+          </a:p>
+          <a:p>
+            <a:pPr algn="l">
+              <a:lnSpc>
+                <a:spcPct val="120000"/>
+              </a:lnSpc>
+            </a:pPr>
+            <a:r>
+              <a:rPr sz="1300" b="1" i="0">
                 <a:solidFill>
                   <a:srgbClr val="F0AB00"/>
                 </a:solidFill>
                 <a:latin typeface="Arial"/>
               </a:rPr>
-              <a:t>· Но карта осталась</a:t>
-            </a:r>
-          </a:p>
-          <a:p>
-            <a:pPr algn="l">
-              <a:lnSpc>
-                <a:spcPct val="125000"/>
-              </a:lnSpc>
-            </a:pPr>
-            <a:r>
-              <a:rPr sz="1100" b="0" i="1">
-                <a:solidFill>
-                  <a:srgbClr val="21295C"/>
-                </a:solidFill>
-                <a:latin typeface="Arial"/>
-              </a:rPr>
-              <a:t>· ~2 000 data files за 15,5 мес работы → retrospective inventory</a:t>
-            </a:r>
-          </a:p>
-          <a:p>
-            <a:pPr algn="l">
-              <a:lnSpc>
-                <a:spcPct val="125000"/>
-              </a:lnSpc>
-            </a:pPr>
-            <a:r>
-              <a:rPr sz="1000" b="0" i="0">
+              <a:t>+ структурная уязвимость</a:t>
+            </a:r>
+          </a:p>
+          <a:p>
+            <a:pPr algn="l">
+              <a:lnSpc>
+                <a:spcPct val="120000"/>
+              </a:lnSpc>
+            </a:pPr>
+            <a:r>
+              <a:rPr sz="1200" b="0" i="0">
+                <a:solidFill>
+                  <a:srgbClr val="21295C"/>
+                </a:solidFill>
+                <a:latin typeface="Arial"/>
+              </a:rPr>
+              <a:t>в одном кадре.</a:t>
+            </a:r>
+          </a:p>
+          <a:p>
+            <a:pPr algn="l">
+              <a:lnSpc>
+                <a:spcPct val="120000"/>
+              </a:lnSpc>
+            </a:pPr>
+            <a:r>
+              <a:rPr sz="600" b="0" i="0">
                 <a:solidFill>
                   <a:srgbClr val="21295C"/>
                 </a:solidFill>
@@ -37863,129 +37859,17 @@
           <a:p>
             <a:pPr algn="l">
               <a:lnSpc>
-                <a:spcPct val="125000"/>
-              </a:lnSpc>
-            </a:pPr>
-            <a:r>
-              <a:rPr sz="1400" b="1" i="0">
-                <a:solidFill>
-                  <a:srgbClr val="065A82"/>
-                </a:solidFill>
-                <a:latin typeface="Arial"/>
-              </a:rPr>
-              <a:t>Final framing:</a:t>
-            </a:r>
-          </a:p>
-          <a:p>
-            <a:pPr algn="l">
-              <a:lnSpc>
-                <a:spcPct val="125000"/>
-              </a:lnSpc>
-            </a:pPr>
-            <a:r>
-              <a:rPr sz="400" b="0" i="0">
-                <a:solidFill>
-                  <a:srgbClr val="21295C"/>
-                </a:solidFill>
-                <a:latin typeface="Arial"/>
-              </a:rPr>
-              <a:t/>
-            </a:r>
-          </a:p>
-          <a:p>
-            <a:pPr algn="l">
-              <a:lnSpc>
-                <a:spcPct val="125000"/>
-              </a:lnSpc>
-            </a:pPr>
-            <a:r>
-              <a:rPr sz="1300" b="0" i="0">
-                <a:solidFill>
-                  <a:srgbClr val="21295C"/>
-                </a:solidFill>
-                <a:latin typeface="Arial"/>
-              </a:rPr>
-              <a:t>AI в нефтегазе —</a:t>
-            </a:r>
-          </a:p>
-          <a:p>
-            <a:pPr algn="l">
-              <a:lnSpc>
-                <a:spcPct val="125000"/>
-              </a:lnSpc>
-            </a:pPr>
-            <a:r>
-              <a:rPr sz="1300" b="1" i="0">
-                <a:solidFill>
-                  <a:srgbClr val="21295C"/>
-                </a:solidFill>
-                <a:latin typeface="Arial"/>
-              </a:rPr>
-              <a:t>это измеримый успех</a:t>
-            </a:r>
-          </a:p>
-          <a:p>
-            <a:pPr algn="l">
-              <a:lnSpc>
-                <a:spcPct val="125000"/>
-              </a:lnSpc>
-            </a:pPr>
-            <a:r>
-              <a:rPr sz="1300" b="1" i="0">
-                <a:solidFill>
-                  <a:srgbClr val="F0AB00"/>
-                </a:solidFill>
-                <a:latin typeface="Arial"/>
-              </a:rPr>
-              <a:t>+ структурная уязвимость</a:t>
-            </a:r>
-          </a:p>
-          <a:p>
-            <a:pPr algn="l">
-              <a:lnSpc>
-                <a:spcPct val="125000"/>
-              </a:lnSpc>
-            </a:pPr>
-            <a:r>
-              <a:rPr sz="1300" b="0" i="0">
-                <a:solidFill>
-                  <a:srgbClr val="21295C"/>
-                </a:solidFill>
-                <a:latin typeface="Arial"/>
-              </a:rPr>
-              <a:t>в одном кадре.</a:t>
-            </a:r>
-          </a:p>
-          <a:p>
-            <a:pPr algn="l">
-              <a:lnSpc>
-                <a:spcPct val="125000"/>
-              </a:lnSpc>
-            </a:pPr>
-            <a:r>
-              <a:rPr sz="600" b="0" i="0">
-                <a:solidFill>
-                  <a:srgbClr val="21295C"/>
-                </a:solidFill>
-                <a:latin typeface="Arial"/>
-              </a:rPr>
-              <a:t/>
-            </a:r>
-          </a:p>
-          <a:p>
-            <a:pPr algn="l">
-              <a:lnSpc>
-                <a:spcPct val="125000"/>
-              </a:lnSpc>
-            </a:pPr>
-            <a:r>
-              <a:rPr sz="1100" b="0" i="1">
-                <a:solidFill>
-                  <a:srgbClr val="21295C"/>
-                </a:solidFill>
-                <a:latin typeface="Arial"/>
-              </a:rPr>
-              <a:t>Хороший инженер строит portfolio reading, не single-quadrant reading.</a:t>
+                <a:spcPct val="120000"/>
+              </a:lnSpc>
+            </a:pPr>
+            <a:r>
+              <a:rPr sz="1000" b="0" i="1">
+                <a:solidFill>
+                  <a:srgbClr val="21295C"/>
+                </a:solidFill>
+                <a:latin typeface="Arial"/>
+              </a:rPr>
+              <a:t>Хороший инженер строит portfolio reading, не single-quadrant.</a:t>
             </a:r>
           </a:p>
         </p:txBody>
@@ -37998,7 +37882,7 @@
         </p:nvSpPr>
         <p:spPr>
           <a:xfrm>
-            <a:off x="457200" y="5897880"/>
+            <a:off x="457200" y="5852160"/>
             <a:ext cx="11274552" cy="640080"/>
           </a:xfrm>
           <a:prstGeom prst="roundRect">
@@ -38046,7 +37930,7 @@
         </p:nvSpPr>
         <p:spPr>
           <a:xfrm>
-            <a:off x="640080" y="5971032"/>
+            <a:off x="640080" y="5925312"/>
             <a:ext cx="10908792" cy="502919"/>
           </a:xfrm>
           <a:prstGeom prst="rect">
@@ -38189,8 +38073,8 @@
         </p:nvSpPr>
         <p:spPr>
           <a:xfrm>
-            <a:off x="274320" y="2743200"/>
-            <a:ext cx="1188720" cy="365760"/>
+            <a:off x="91440" y="1554480"/>
+            <a:ext cx="1371600" cy="365760"/>
           </a:xfrm>
           <a:prstGeom prst="rect">
             <a:avLst/>
@@ -38209,13 +38093,13 @@
               </a:lnSpc>
             </a:pPr>
             <a:r>
-              <a:rPr sz="1200" b="1" i="0">
+              <a:rPr sz="1100" b="1" i="0">
                 <a:solidFill>
                   <a:srgbClr val="065A82"/>
                 </a:solidFill>
                 <a:latin typeface="Arial"/>
               </a:rPr>
-              <a:t>Данные →</a:t>
+              <a:t>Высокая ↑</a:t>
             </a:r>
           </a:p>
         </p:txBody>
@@ -38228,8 +38112,8 @@
         </p:nvSpPr>
         <p:spPr>
           <a:xfrm>
-            <a:off x="274320" y="1645920"/>
-            <a:ext cx="1188720" cy="365760"/>
+            <a:off x="91440" y="3383280"/>
+            <a:ext cx="1371600" cy="457200"/>
           </a:xfrm>
           <a:prstGeom prst="rect">
             <a:avLst/>
@@ -38248,13 +38132,13 @@
               </a:lnSpc>
             </a:pPr>
             <a:r>
-              <a:rPr sz="1000" b="0" i="0">
-                <a:solidFill>
-                  <a:srgbClr val="6B7685"/>
-                </a:solidFill>
-                <a:latin typeface="Arial"/>
-              </a:rPr>
-              <a:t>↑ Высокая</a:t>
+              <a:rPr sz="1400" b="1" i="0">
+                <a:solidFill>
+                  <a:srgbClr val="065A82"/>
+                </a:solidFill>
+                <a:latin typeface="Arial"/>
+              </a:rPr>
+              <a:t>Данные</a:t>
             </a:r>
           </a:p>
         </p:txBody>
@@ -38267,8 +38151,8 @@
         </p:nvSpPr>
         <p:spPr>
           <a:xfrm>
-            <a:off x="274320" y="5120640"/>
-            <a:ext cx="1188720" cy="365760"/>
+            <a:off x="91440" y="5074920"/>
+            <a:ext cx="1371600" cy="365760"/>
           </a:xfrm>
           <a:prstGeom prst="rect">
             <a:avLst/>
@@ -38287,9 +38171,9 @@
               </a:lnSpc>
             </a:pPr>
             <a:r>
-              <a:rPr sz="1000" b="0" i="0">
-                <a:solidFill>
-                  <a:srgbClr val="6B7685"/>
+              <a:rPr sz="1100" b="1" i="0">
+                <a:solidFill>
+                  <a:srgbClr val="065A82"/>
                 </a:solidFill>
                 <a:latin typeface="Arial"/>
               </a:rPr>
@@ -38306,8 +38190,8 @@
         </p:nvSpPr>
         <p:spPr>
           <a:xfrm>
-            <a:off x="2560320" y="5852160"/>
-            <a:ext cx="3200400" cy="365760"/>
+            <a:off x="1828800" y="5852160"/>
+            <a:ext cx="3657600" cy="365760"/>
           </a:xfrm>
           <a:prstGeom prst="rect">
             <a:avLst/>
@@ -38326,9 +38210,9 @@
               </a:lnSpc>
             </a:pPr>
             <a:r>
-              <a:rPr sz="1000" b="0" i="0">
-                <a:solidFill>
-                  <a:srgbClr val="6B7685"/>
+              <a:rPr sz="1100" b="1" i="0">
+                <a:solidFill>
+                  <a:srgbClr val="065A82"/>
                 </a:solidFill>
                 <a:latin typeface="Arial"/>
               </a:rPr>
@@ -38345,8 +38229,8 @@
         </p:nvSpPr>
         <p:spPr>
           <a:xfrm>
-            <a:off x="7498079" y="5852160"/>
-            <a:ext cx="3200400" cy="365760"/>
+            <a:off x="5029200" y="5852160"/>
+            <a:ext cx="2286000" cy="457200"/>
           </a:xfrm>
           <a:prstGeom prst="rect">
             <a:avLst/>
@@ -38365,13 +38249,13 @@
               </a:lnSpc>
             </a:pPr>
             <a:r>
-              <a:rPr sz="1000" b="0" i="0">
-                <a:solidFill>
-                  <a:srgbClr val="6B7685"/>
-                </a:solidFill>
-                <a:latin typeface="Arial"/>
-              </a:rPr>
-              <a:t>Высокая →</a:t>
+              <a:rPr sz="1400" b="1" i="0">
+                <a:solidFill>
+                  <a:srgbClr val="065A82"/>
+                </a:solidFill>
+                <a:latin typeface="Arial"/>
+              </a:rPr>
+              <a:t>Физика</a:t>
             </a:r>
           </a:p>
         </p:txBody>
@@ -38384,8 +38268,8 @@
         </p:nvSpPr>
         <p:spPr>
           <a:xfrm>
-            <a:off x="4114800" y="6126480"/>
-            <a:ext cx="4114800" cy="365760"/>
+            <a:off x="6858000" y="5852160"/>
+            <a:ext cx="3657600" cy="365760"/>
           </a:xfrm>
           <a:prstGeom prst="rect">
             <a:avLst/>
@@ -38404,13 +38288,13 @@
               </a:lnSpc>
             </a:pPr>
             <a:r>
-              <a:rPr sz="1200" b="1" i="0">
+              <a:rPr sz="1100" b="1" i="0">
                 <a:solidFill>
                   <a:srgbClr val="065A82"/>
                 </a:solidFill>
                 <a:latin typeface="Arial"/>
               </a:rPr>
-              <a:t>Физика →</a:t>
+              <a:t>Высокая →</a:t>
             </a:r>
           </a:p>
         </p:txBody>
@@ -38423,7 +38307,7 @@
         </p:nvSpPr>
         <p:spPr>
           <a:xfrm>
-            <a:off x="1554480" y="1463040"/>
+            <a:off x="1554480" y="1417320"/>
             <a:ext cx="4572000" cy="2057400"/>
           </a:xfrm>
           <a:prstGeom prst="roundRect">
@@ -38471,7 +38355,7 @@
         </p:nvSpPr>
         <p:spPr>
           <a:xfrm>
-            <a:off x="1737360" y="1554480"/>
+            <a:off x="1737360" y="1508760"/>
             <a:ext cx="4206240" cy="457200"/>
           </a:xfrm>
           <a:prstGeom prst="rect">
@@ -38497,7 +38381,7 @@
                 </a:solidFill>
                 <a:latin typeface="Arial"/>
               </a:rPr>
-              <a:t>Q2 — Methane MRV</a:t>
+              <a:t>Q2 — Метановая MRV</a:t>
             </a:r>
           </a:p>
         </p:txBody>
@@ -38510,7 +38394,7 @@
         </p:nvSpPr>
         <p:spPr>
           <a:xfrm>
-            <a:off x="1737360" y="2103120"/>
+            <a:off x="1737360" y="2057400"/>
             <a:ext cx="4206240" cy="1280160"/>
           </a:xfrm>
           <a:prstGeom prst="rect">
@@ -38536,7 +38420,7 @@
                 </a:solidFill>
                 <a:latin typeface="Arial"/>
               </a:rPr>
-              <a:t>AI essential
+              <a:t>AI необходим
 MethaneSAT / Carbon Mapper / GHGSat</a:t>
             </a:r>
           </a:p>
@@ -38550,7 +38434,7 @@
         </p:nvSpPr>
         <p:spPr>
           <a:xfrm>
-            <a:off x="6309360" y="1463040"/>
+            <a:off x="6309360" y="1417320"/>
             <a:ext cx="4572000" cy="2057400"/>
           </a:xfrm>
           <a:prstGeom prst="roundRect">
@@ -38598,7 +38482,7 @@
         </p:nvSpPr>
         <p:spPr>
           <a:xfrm>
-            <a:off x="6492240" y="1554480"/>
+            <a:off x="6492240" y="1508760"/>
             <a:ext cx="4206240" cy="457200"/>
           </a:xfrm>
           <a:prstGeom prst="rect">
@@ -38624,7 +38508,7 @@
                 </a:solidFill>
                 <a:latin typeface="Arial"/>
               </a:rPr>
-              <a:t>Q1 — Mature production</a:t>
+              <a:t>Q1 — Зрелое производство</a:t>
             </a:r>
           </a:p>
         </p:txBody>
@@ -38637,7 +38521,7 @@
         </p:nvSpPr>
         <p:spPr>
           <a:xfrm>
-            <a:off x="6492240" y="2103120"/>
+            <a:off x="6492240" y="2057400"/>
             <a:ext cx="4206240" cy="1280160"/>
           </a:xfrm>
           <a:prstGeom prst="rect">
@@ -38663,8 +38547,8 @@
                 </a:solidFill>
                 <a:latin typeface="Arial"/>
               </a:rPr>
-              <a:t>AI мультипликатор
-Ambyint +15% на 200 wells</a:t>
+              <a:t>AI как мультипликатор
+Ambyint +15% на 200 скважинах</a:t>
             </a:r>
           </a:p>
         </p:txBody>
@@ -38677,7 +38561,7 @@
         </p:nvSpPr>
         <p:spPr>
           <a:xfrm>
-            <a:off x="1554480" y="3657600"/>
+            <a:off x="1554480" y="3611880"/>
             <a:ext cx="4572000" cy="2057400"/>
           </a:xfrm>
           <a:prstGeom prst="roundRect">
@@ -38725,7 +38609,7 @@
         </p:nvSpPr>
         <p:spPr>
           <a:xfrm>
-            <a:off x="1737360" y="3749039"/>
+            <a:off x="1737360" y="3703320"/>
             <a:ext cx="4206240" cy="457200"/>
           </a:xfrm>
           <a:prstGeom prst="rect">
@@ -38751,7 +38635,7 @@
                 </a:solidFill>
                 <a:latin typeface="Arial"/>
               </a:rPr>
-              <a:t>Q4 — Energy transition</a:t>
+              <a:t>Q4 — Энергопереход</a:t>
             </a:r>
           </a:p>
         </p:txBody>
@@ -38764,7 +38648,7 @@
         </p:nvSpPr>
         <p:spPr>
           <a:xfrm>
-            <a:off x="1737360" y="4297680"/>
+            <a:off x="1737360" y="4251960"/>
             <a:ext cx="4206240" cy="1280160"/>
           </a:xfrm>
           <a:prstGeom prst="rect">
@@ -38790,7 +38674,7 @@
                 </a:solidFill>
                 <a:latin typeface="Arial"/>
               </a:rPr>
-              <a:t>AI и физика struggle вместе
+              <a:t>AI и физика буксуют вместе
 Northern Lights / Fervo</a:t>
             </a:r>
           </a:p>
@@ -38804,7 +38688,7 @@
         </p:nvSpPr>
         <p:spPr>
           <a:xfrm>
-            <a:off x="6309360" y="3657600"/>
+            <a:off x="6309360" y="3611880"/>
             <a:ext cx="4572000" cy="2057400"/>
           </a:xfrm>
           <a:prstGeom prst="roundRect">
@@ -38852,7 +38736,7 @@
         </p:nvSpPr>
         <p:spPr>
           <a:xfrm>
-            <a:off x="6492240" y="3749039"/>
+            <a:off x="6492240" y="3703320"/>
             <a:ext cx="4206240" cy="457200"/>
           </a:xfrm>
           <a:prstGeom prst="rect">
@@ -38878,7 +38762,7 @@
                 </a:solidFill>
                 <a:latin typeface="Arial"/>
               </a:rPr>
-              <a:t>Q3 — Frontier exploration</a:t>
+              <a:t>Q3 — Разведка фронтиров</a:t>
             </a:r>
           </a:p>
         </p:txBody>
@@ -38891,7 +38775,7 @@
         </p:nvSpPr>
         <p:spPr>
           <a:xfrm>
-            <a:off x="6492240" y="4297680"/>
+            <a:off x="6492240" y="4251960"/>
             <a:ext cx="4206240" cy="1280160"/>
           </a:xfrm>
           <a:prstGeom prst="rect">
@@ -38917,7 +38801,7 @@
                 </a:solidFill>
                 <a:latin typeface="Arial"/>
               </a:rPr>
-              <a:t>Physics-first, AI augmentation
+              <a:t>Physics-first, AI как дополнение
 Aramco METABRAIN / Eni HPC6</a:t>
             </a:r>
           </a:p>
@@ -38931,7 +38815,7 @@
         </p:nvSpPr>
         <p:spPr>
           <a:xfrm>
-            <a:off x="457200" y="6355080"/>
+            <a:off x="457200" y="6400800"/>
             <a:ext cx="11274552" cy="411480"/>
           </a:xfrm>
           <a:prstGeom prst="roundRect">
@@ -38979,7 +38863,7 @@
         </p:nvSpPr>
         <p:spPr>
           <a:xfrm>
-            <a:off x="640080" y="6428232"/>
+            <a:off x="640080" y="6473952"/>
             <a:ext cx="10908792" cy="274320"/>
           </a:xfrm>
           <a:prstGeom prst="rect">
@@ -39612,7 +39496,7 @@
                 </a:solidFill>
                 <a:latin typeface="Arial"/>
               </a:rPr>
-              <a:t>7. Cross-cutting</a:t>
+              <a:t>7. Сквозные</a:t>
             </a:r>
           </a:p>
         </p:txBody>
@@ -39626,7 +39510,7 @@
         <p:spPr>
           <a:xfrm>
             <a:off x="457200" y="914400"/>
-            <a:ext cx="5029200" cy="4114800"/>
+            <a:ext cx="5029200" cy="3291840"/>
           </a:xfrm>
           <a:prstGeom prst="rect">
             <a:avLst/>
@@ -39664,8 +39548,8 @@
         </p:nvSpPr>
         <p:spPr>
           <a:xfrm>
-            <a:off x="457200" y="4389120"/>
-            <a:ext cx="5029200" cy="548640"/>
+            <a:off x="457200" y="4434840"/>
+            <a:ext cx="5029200" cy="502920"/>
           </a:xfrm>
           <a:prstGeom prst="rect">
             <a:avLst/>
@@ -39684,13 +39568,13 @@
               </a:lnSpc>
             </a:pPr>
             <a:r>
-              <a:rPr sz="2400" b="1" i="0">
-                <a:solidFill>
-                  <a:srgbClr val="21295C"/>
-                </a:solidFill>
-                <a:latin typeface="Arial"/>
-              </a:rPr>
-              <a:t>Mature production</a:t>
+              <a:rPr sz="2200" b="1" i="0">
+                <a:solidFill>
+                  <a:srgbClr val="21295C"/>
+                </a:solidFill>
+                <a:latin typeface="Arial"/>
+              </a:rPr>
+              <a:t>Зрелое производство</a:t>
             </a:r>
           </a:p>
         </p:txBody>
@@ -39816,7 +39700,7 @@
                 </a:solidFill>
                 <a:latin typeface="Arial"/>
               </a:rPr>
-              <a:t>3 working cases · 2 структурных провала · 86% pilot stuck — статистическая норма</a:t>
+              <a:t>3 рабочих кейса · 2 структурных провала · 86% пилотов застряло — статистическая норма</a:t>
             </a:r>
           </a:p>
         </p:txBody>
@@ -40365,7 +40249,7 @@
         </p:nvSpPr>
         <p:spPr>
           <a:xfrm>
-            <a:off x="457200" y="365760"/>
+            <a:off x="457200" y="320040"/>
             <a:ext cx="11274552" cy="777240"/>
           </a:xfrm>
           <a:prstGeom prst="rect">
@@ -40385,7 +40269,7 @@
               </a:lnSpc>
             </a:pPr>
             <a:r>
-              <a:rPr sz="2400" b="1" i="0">
+              <a:rPr sz="2200" b="1" i="0">
                 <a:solidFill>
                   <a:srgbClr val="21295C"/>
                 </a:solidFill>
@@ -40404,7 +40288,7 @@
         </p:nvSpPr>
         <p:spPr>
           <a:xfrm>
-            <a:off x="457200" y="1143000"/>
+            <a:off x="457200" y="1097280"/>
             <a:ext cx="11274552" cy="365760"/>
           </a:xfrm>
           <a:prstGeom prst="rect">
@@ -40443,8 +40327,8 @@
         </p:nvSpPr>
         <p:spPr>
           <a:xfrm>
-            <a:off x="457200" y="1691640"/>
-            <a:ext cx="5029200" cy="4023360"/>
+            <a:off x="457200" y="1554480"/>
+            <a:ext cx="5029200" cy="4114800"/>
           </a:xfrm>
           <a:prstGeom prst="roundRect">
             <a:avLst>
@@ -40499,7 +40383,7 @@
         </p:blipFill>
         <p:spPr>
           <a:xfrm>
-            <a:off x="640080" y="3050381"/>
+            <a:off x="640080" y="2913221"/>
             <a:ext cx="4663440" cy="1214437"/>
           </a:xfrm>
           <a:prstGeom prst="rect">
@@ -40515,7 +40399,7 @@
         </p:nvSpPr>
         <p:spPr>
           <a:xfrm>
-            <a:off x="640080" y="5486400"/>
+            <a:off x="640080" y="5349240"/>
             <a:ext cx="4572000" cy="274320"/>
           </a:xfrm>
           <a:prstGeom prst="rect">
@@ -40554,8 +40438,8 @@
         </p:nvSpPr>
         <p:spPr>
           <a:xfrm>
-            <a:off x="5669280" y="1691640"/>
-            <a:ext cx="6062472" cy="4023360"/>
+            <a:off x="5669280" y="1554480"/>
+            <a:ext cx="6062472" cy="4114800"/>
           </a:xfrm>
           <a:prstGeom prst="roundRect">
             <a:avLst>
@@ -40602,8 +40486,8 @@
         </p:nvSpPr>
         <p:spPr>
           <a:xfrm>
-            <a:off x="5852160" y="1783080"/>
-            <a:ext cx="5760720" cy="3840480"/>
+            <a:off x="5852160" y="1645920"/>
+            <a:ext cx="5760720" cy="4023360"/>
           </a:xfrm>
           <a:prstGeom prst="rect">
             <a:avLst/>
@@ -40817,7 +40701,7 @@
         </p:nvSpPr>
         <p:spPr>
           <a:xfrm>
-            <a:off x="457200" y="5943600"/>
+            <a:off x="457200" y="5806440"/>
             <a:ext cx="11274552" cy="502920"/>
           </a:xfrm>
           <a:prstGeom prst="roundRect">
@@ -40865,7 +40749,7 @@
         </p:nvSpPr>
         <p:spPr>
           <a:xfrm>
-            <a:off x="640080" y="6016752"/>
+            <a:off x="640080" y="5879592"/>
             <a:ext cx="10908792" cy="365760"/>
           </a:xfrm>
           <a:prstGeom prst="rect">

</xml_diff>